<commit_message>
Move floor headline to org detail slide; new two-year headline on headcount slide
Co-Authored-By: Claude Opus 5.5 <noreply@anthropic.com>
Claude-Session: https://claude.ai/code/session_01JXKaD9UU8MgeRWUr7sq4Za
</commit_message>
<xml_diff>
--- a/MADE Team Strategy.pptx
+++ b/MADE Team Strategy.pptx
@@ -116,13 +116,13 @@
   <p:extLst>
     <p:ext uri="{521415D9-36F7-43E2-AB2F-B90AF26B5E84}">
       <p14:sectionLst xmlns:p14="http://schemas.microsoft.com/office/powerpoint/2010/main">
-        <p14:section name="Why combine" id="{a4bf5252-fc17-e586-8f22-2a336cab0c51}">
+        <p14:section name="Why combine" id="{9232d4b0-2463-3986-fbc1-2225c8dd848f}">
           <p14:sldIdLst>
             <p14:sldId id="256"/>
             <p14:sldId id="257"/>
           </p14:sldIdLst>
         </p14:section>
-        <p14:section name="How we organize" id="{f83c7d59-025a-adf2-bfb6-e6e2895b3f78}">
+        <p14:section name="How we organize" id="{f4fb8f0a-e197-aad1-c5e2-c7f5d3b80b93}">
           <p14:sldIdLst>
             <p14:sldId id="258"/>
             <p14:sldId id="259"/>
@@ -130,14 +130,14 @@
             <p14:sldId id="261"/>
           </p14:sldIdLst>
         </p14:section>
-        <p14:section name="What we do and how we grow" id="{d46d9099-cade-b112-6636-c4377a267b1f}">
+        <p14:section name="What we do and how we grow" id="{c4b3ff5b-5065-1eb9-e03a-13b8d7aa32f5}">
           <p14:sldIdLst>
             <p14:sldId id="262"/>
             <p14:sldId id="263"/>
             <p14:sldId id="264"/>
           </p14:sldIdLst>
         </p14:section>
-        <p14:section name="Asks" id="{d0e8b337-c60d-eb72-a597-89cd0b3860eb}">
+        <p14:section name="Asks" id="{e9fbe43e-bc8c-21ec-6d57-03252691386e}">
           <p14:sldIdLst>
             <p14:sldId id="265"/>
           </p14:sldIdLst>
@@ -986,7 +986,7 @@
           <a:p>
             <a:r>
               <a:rPr lang="en-US" dirty="0"/>
-              <a:t>This rolls up the team-by-team plan on the previous slide. The end-2026 count includes open roles; 2027 and 2028 assume every role is filled. The story, from the end of this year to the end of 2028: today almost all capacity goes to BAU, and dedicated AI work is near zero. AI and new tooling let BAU shrink step by step (the end of 2027 shows the midpoint), but only down to a floor. That floor, [n] people, is the sum of the team-level floors on the previous slide: the minimum BAU team we need to manage operational risk: critical functions like model deployment must never depend on one person whose departure takes all the knowledge with them. Rotation and cross-functional mixing keep that floor as low as safely possible, but we will not go below it, and the 2028 target deliberately sits above it. Everything freed above the floor moves to AI-focused work, the change-the-business end of the structure. Any net headcount reduction is a by-product, shown as the dashed box.</a:t>
+              <a:t>Headline: within two years, about a quarter of today’s BAU headcount is freed up and either repurposed to support AI growth or released through efficiency gains. This rolls up the team-by-team plan on the previous slide. The end-2026 count includes open roles; 2027 and 2028 assume every role is filled. The story, from the end of this year to the end of 2028: today almost all capacity goes to BAU, and dedicated AI work is near zero. AI and new tooling let BAU shrink step by step (the end of 2027 shows the midpoint), but only down to a floor. That floor, [n] people, is the sum of the team-level floors on the previous slide: the minimum BAU team we need to manage operational risk: critical functions like model deployment must never depend on one person whose departure takes all the knowledge with them. Rotation and cross-functional mixing keep that floor as low as safely possible, but we will not go below it, and the 2028 target deliberately sits above it. Everything freed above the floor moves to AI-focused work, the change-the-business end of the structure. Any net headcount reduction is a by-product, shown as the dashed box.</a:t>
             </a:r>
             <a:endParaRPr lang="en-US" dirty="0"/>
           </a:p>
@@ -6983,7 +6983,7 @@
                 <a:ea typeface="Optimist Display" pitchFamily="34" charset="-122"/>
                 <a:cs typeface="Optimist Display" pitchFamily="34" charset="-120"/>
               </a:rPr>
-              <a:t>BAU-heavy teams shrink as AI Enablement grows</a:t>
+              <a:t>AI shrinks BAU down to a firm risk floor, and the freed capacity builds AI work from near zero</a:t>
             </a:r>
             <a:endParaRPr lang="en-US" sz="3200" dirty="0"/>
           </a:p>
@@ -6997,8 +6997,8 @@
         </p:nvSpPr>
         <p:spPr>
           <a:xfrm>
-            <a:off x="6096000" y="2463800"/>
-            <a:ext cx="914" cy="127000"/>
+            <a:off x="6096000" y="2844800"/>
+            <a:ext cx="914" cy="50800"/>
           </a:xfrm>
           <a:prstGeom prst="line">
             <a:avLst/>
@@ -7020,7 +7020,7 @@
         </p:nvSpPr>
         <p:spPr>
           <a:xfrm>
-            <a:off x="3200400" y="2590800"/>
+            <a:off x="3200400" y="2895600"/>
             <a:ext cx="7289800" cy="914"/>
           </a:xfrm>
           <a:prstGeom prst="line">
@@ -7043,8 +7043,8 @@
         </p:nvSpPr>
         <p:spPr>
           <a:xfrm>
-            <a:off x="3200400" y="2590800"/>
-            <a:ext cx="914" cy="127000"/>
+            <a:off x="3200400" y="2895600"/>
+            <a:ext cx="914" cy="50800"/>
           </a:xfrm>
           <a:prstGeom prst="line">
             <a:avLst/>
@@ -7066,8 +7066,8 @@
         </p:nvSpPr>
         <p:spPr>
           <a:xfrm>
-            <a:off x="6629400" y="2590800"/>
-            <a:ext cx="914" cy="127000"/>
+            <a:off x="6629400" y="2895600"/>
+            <a:ext cx="914" cy="50800"/>
           </a:xfrm>
           <a:prstGeom prst="line">
             <a:avLst/>
@@ -7089,8 +7089,8 @@
         </p:nvSpPr>
         <p:spPr>
           <a:xfrm>
-            <a:off x="8559800" y="2590800"/>
-            <a:ext cx="914" cy="127000"/>
+            <a:off x="8559800" y="2895600"/>
+            <a:ext cx="914" cy="50800"/>
           </a:xfrm>
           <a:prstGeom prst="line">
             <a:avLst/>
@@ -7112,8 +7112,8 @@
         </p:nvSpPr>
         <p:spPr>
           <a:xfrm>
-            <a:off x="10490200" y="2590800"/>
-            <a:ext cx="914" cy="127000"/>
+            <a:off x="10490200" y="2895600"/>
+            <a:ext cx="914" cy="50800"/>
           </a:xfrm>
           <a:prstGeom prst="line">
             <a:avLst/>
@@ -7135,8 +7135,8 @@
         </p:nvSpPr>
         <p:spPr>
           <a:xfrm>
-            <a:off x="3200400" y="3378200"/>
-            <a:ext cx="914" cy="101600"/>
+            <a:off x="3200400" y="3606800"/>
+            <a:ext cx="914" cy="50800"/>
           </a:xfrm>
           <a:prstGeom prst="line">
             <a:avLst/>
@@ -7158,7 +7158,7 @@
         </p:nvSpPr>
         <p:spPr>
           <a:xfrm>
-            <a:off x="1574800" y="3479800"/>
+            <a:off x="1574800" y="3657600"/>
             <a:ext cx="3251200" cy="914"/>
           </a:xfrm>
           <a:prstGeom prst="line">
@@ -7181,8 +7181,8 @@
         </p:nvSpPr>
         <p:spPr>
           <a:xfrm>
-            <a:off x="1574800" y="3479800"/>
-            <a:ext cx="914" cy="101600"/>
+            <a:off x="1574800" y="3657600"/>
+            <a:ext cx="914" cy="50800"/>
           </a:xfrm>
           <a:prstGeom prst="line">
             <a:avLst/>
@@ -7204,8 +7204,8 @@
         </p:nvSpPr>
         <p:spPr>
           <a:xfrm>
-            <a:off x="1574800" y="4089400"/>
-            <a:ext cx="914" cy="101600"/>
+            <a:off x="1574800" y="4216400"/>
+            <a:ext cx="914" cy="63500"/>
           </a:xfrm>
           <a:prstGeom prst="line">
             <a:avLst/>
@@ -7227,8 +7227,8 @@
         </p:nvSpPr>
         <p:spPr>
           <a:xfrm>
-            <a:off x="3200400" y="3479800"/>
-            <a:ext cx="914" cy="101600"/>
+            <a:off x="3200400" y="3657600"/>
+            <a:ext cx="914" cy="50800"/>
           </a:xfrm>
           <a:prstGeom prst="line">
             <a:avLst/>
@@ -7250,8 +7250,8 @@
         </p:nvSpPr>
         <p:spPr>
           <a:xfrm>
-            <a:off x="3200400" y="4089400"/>
-            <a:ext cx="914" cy="101600"/>
+            <a:off x="3200400" y="4216400"/>
+            <a:ext cx="914" cy="63500"/>
           </a:xfrm>
           <a:prstGeom prst="line">
             <a:avLst/>
@@ -7273,8 +7273,8 @@
         </p:nvSpPr>
         <p:spPr>
           <a:xfrm>
-            <a:off x="4826000" y="3479800"/>
-            <a:ext cx="914" cy="101600"/>
+            <a:off x="4826000" y="3657600"/>
+            <a:ext cx="914" cy="50800"/>
           </a:xfrm>
           <a:prstGeom prst="line">
             <a:avLst/>
@@ -7296,8 +7296,8 @@
         </p:nvSpPr>
         <p:spPr>
           <a:xfrm>
-            <a:off x="4826000" y="4089400"/>
-            <a:ext cx="914" cy="101600"/>
+            <a:off x="4826000" y="4216400"/>
+            <a:ext cx="914" cy="63500"/>
           </a:xfrm>
           <a:prstGeom prst="line">
             <a:avLst/>
@@ -7319,8 +7319,8 @@
         </p:nvSpPr>
         <p:spPr>
           <a:xfrm>
-            <a:off x="6629400" y="3378200"/>
-            <a:ext cx="914" cy="203200"/>
+            <a:off x="6629400" y="3606800"/>
+            <a:ext cx="914" cy="101600"/>
           </a:xfrm>
           <a:prstGeom prst="line">
             <a:avLst/>
@@ -7342,8 +7342,8 @@
         </p:nvSpPr>
         <p:spPr>
           <a:xfrm>
-            <a:off x="8559800" y="3378200"/>
-            <a:ext cx="914" cy="203200"/>
+            <a:off x="8559800" y="3606800"/>
+            <a:ext cx="914" cy="101600"/>
           </a:xfrm>
           <a:prstGeom prst="line">
             <a:avLst/>
@@ -7365,8 +7365,8 @@
         </p:nvSpPr>
         <p:spPr>
           <a:xfrm>
-            <a:off x="10490200" y="3378200"/>
-            <a:ext cx="914" cy="203200"/>
+            <a:off x="10490200" y="3606800"/>
+            <a:ext cx="914" cy="101600"/>
           </a:xfrm>
           <a:prstGeom prst="line">
             <a:avLst/>
@@ -7388,7 +7388,7 @@
         </p:nvSpPr>
         <p:spPr>
           <a:xfrm>
-            <a:off x="4826000" y="2108200"/>
+            <a:off x="4826000" y="2489200"/>
             <a:ext cx="2540000" cy="355600"/>
           </a:xfrm>
           <a:prstGeom prst="roundRect">
@@ -7410,7 +7410,7 @@
         </p:nvSpPr>
         <p:spPr>
           <a:xfrm>
-            <a:off x="4826000" y="2108200"/>
+            <a:off x="4826000" y="2489200"/>
             <a:ext cx="2540000" cy="355600"/>
           </a:xfrm>
           <a:prstGeom prst="rect">
@@ -7452,7 +7452,7 @@
         </p:nvSpPr>
         <p:spPr>
           <a:xfrm>
-            <a:off x="812800" y="2717800"/>
+            <a:off x="812800" y="2946400"/>
             <a:ext cx="4775200" cy="660400"/>
           </a:xfrm>
           <a:prstGeom prst="roundRect">
@@ -7479,7 +7479,7 @@
         </p:nvSpPr>
         <p:spPr>
           <a:xfrm>
-            <a:off x="901700" y="2768600"/>
+            <a:off x="901700" y="2997200"/>
             <a:ext cx="4597400" cy="558800"/>
           </a:xfrm>
           <a:prstGeom prst="rect">
@@ -7541,7 +7541,7 @@
         </p:nvSpPr>
         <p:spPr>
           <a:xfrm>
-            <a:off x="5740400" y="2717800"/>
+            <a:off x="5740400" y="2946400"/>
             <a:ext cx="1778000" cy="660400"/>
           </a:xfrm>
           <a:prstGeom prst="roundRect">
@@ -7568,7 +7568,7 @@
         </p:nvSpPr>
         <p:spPr>
           <a:xfrm>
-            <a:off x="5829300" y="2768600"/>
+            <a:off x="5829300" y="2997200"/>
             <a:ext cx="1600200" cy="558800"/>
           </a:xfrm>
           <a:prstGeom prst="rect">
@@ -7630,7 +7630,7 @@
         </p:nvSpPr>
         <p:spPr>
           <a:xfrm>
-            <a:off x="7670800" y="2717800"/>
+            <a:off x="7670800" y="2946400"/>
             <a:ext cx="1778000" cy="660400"/>
           </a:xfrm>
           <a:prstGeom prst="roundRect">
@@ -7657,7 +7657,7 @@
         </p:nvSpPr>
         <p:spPr>
           <a:xfrm>
-            <a:off x="7759700" y="2768600"/>
+            <a:off x="7759700" y="2997200"/>
             <a:ext cx="1600200" cy="558800"/>
           </a:xfrm>
           <a:prstGeom prst="rect">
@@ -7719,7 +7719,7 @@
         </p:nvSpPr>
         <p:spPr>
           <a:xfrm>
-            <a:off x="9601200" y="2717800"/>
+            <a:off x="9601200" y="2946400"/>
             <a:ext cx="1778000" cy="660400"/>
           </a:xfrm>
           <a:prstGeom prst="roundRect">
@@ -7746,7 +7746,7 @@
         </p:nvSpPr>
         <p:spPr>
           <a:xfrm>
-            <a:off x="9690100" y="2768600"/>
+            <a:off x="9690100" y="2997200"/>
             <a:ext cx="1600200" cy="558800"/>
           </a:xfrm>
           <a:prstGeom prst="rect">
@@ -7808,7 +7808,7 @@
         </p:nvSpPr>
         <p:spPr>
           <a:xfrm>
-            <a:off x="812800" y="3581400"/>
+            <a:off x="812800" y="3708400"/>
             <a:ext cx="1524000" cy="508000"/>
           </a:xfrm>
           <a:prstGeom prst="roundRect">
@@ -7835,7 +7835,7 @@
         </p:nvSpPr>
         <p:spPr>
           <a:xfrm>
-            <a:off x="901700" y="3619500"/>
+            <a:off x="901700" y="3746500"/>
             <a:ext cx="1346200" cy="431800"/>
           </a:xfrm>
           <a:prstGeom prst="rect">
@@ -7897,7 +7897,7 @@
         </p:nvSpPr>
         <p:spPr>
           <a:xfrm>
-            <a:off x="2438400" y="3581400"/>
+            <a:off x="2438400" y="3708400"/>
             <a:ext cx="1524000" cy="508000"/>
           </a:xfrm>
           <a:prstGeom prst="roundRect">
@@ -7924,7 +7924,7 @@
         </p:nvSpPr>
         <p:spPr>
           <a:xfrm>
-            <a:off x="2527300" y="3619500"/>
+            <a:off x="2527300" y="3746500"/>
             <a:ext cx="1346200" cy="431800"/>
           </a:xfrm>
           <a:prstGeom prst="rect">
@@ -7986,7 +7986,7 @@
         </p:nvSpPr>
         <p:spPr>
           <a:xfrm>
-            <a:off x="4064000" y="3581400"/>
+            <a:off x="4064000" y="3708400"/>
             <a:ext cx="1524000" cy="508000"/>
           </a:xfrm>
           <a:prstGeom prst="roundRect">
@@ -8013,7 +8013,7 @@
         </p:nvSpPr>
         <p:spPr>
           <a:xfrm>
-            <a:off x="4152900" y="3619500"/>
+            <a:off x="4152900" y="3746500"/>
             <a:ext cx="1346200" cy="431800"/>
           </a:xfrm>
           <a:prstGeom prst="rect">
@@ -8075,8 +8075,8 @@
         </p:nvSpPr>
         <p:spPr>
           <a:xfrm>
-            <a:off x="812800" y="4191000"/>
-            <a:ext cx="1524000" cy="1651000"/>
+            <a:off x="812800" y="4279900"/>
+            <a:ext cx="1524000" cy="1562100"/>
           </a:xfrm>
           <a:prstGeom prst="roundRect">
             <a:avLst>
@@ -8102,7 +8102,7 @@
         </p:nvSpPr>
         <p:spPr>
           <a:xfrm>
-            <a:off x="914400" y="4267200"/>
+            <a:off x="914400" y="4356100"/>
             <a:ext cx="1320800" cy="590550"/>
           </a:xfrm>
           <a:prstGeom prst="rect">
@@ -8584,8 +8584,8 @@
         </p:nvSpPr>
         <p:spPr>
           <a:xfrm>
-            <a:off x="2438400" y="4191000"/>
-            <a:ext cx="1524000" cy="1651000"/>
+            <a:off x="2438400" y="4279900"/>
+            <a:ext cx="1524000" cy="1562100"/>
           </a:xfrm>
           <a:prstGeom prst="roundRect">
             <a:avLst>
@@ -8611,7 +8611,7 @@
         </p:nvSpPr>
         <p:spPr>
           <a:xfrm>
-            <a:off x="2540000" y="4267200"/>
+            <a:off x="2540000" y="4356100"/>
             <a:ext cx="1320800" cy="590550"/>
           </a:xfrm>
           <a:prstGeom prst="rect">
@@ -9093,8 +9093,8 @@
         </p:nvSpPr>
         <p:spPr>
           <a:xfrm>
-            <a:off x="4064000" y="4191000"/>
-            <a:ext cx="1524000" cy="1651000"/>
+            <a:off x="4064000" y="4279900"/>
+            <a:ext cx="1524000" cy="1562100"/>
           </a:xfrm>
           <a:prstGeom prst="roundRect">
             <a:avLst>
@@ -9120,7 +9120,7 @@
         </p:nvSpPr>
         <p:spPr>
           <a:xfrm>
-            <a:off x="4165600" y="4267200"/>
+            <a:off x="4165600" y="4356100"/>
             <a:ext cx="1320800" cy="590550"/>
           </a:xfrm>
           <a:prstGeom prst="rect">
@@ -9602,8 +9602,8 @@
         </p:nvSpPr>
         <p:spPr>
           <a:xfrm>
-            <a:off x="5740400" y="3581400"/>
-            <a:ext cx="1778000" cy="2260600"/>
+            <a:off x="5740400" y="3708400"/>
+            <a:ext cx="1778000" cy="2133600"/>
           </a:xfrm>
           <a:prstGeom prst="roundRect">
             <a:avLst>
@@ -9629,7 +9629,7 @@
         </p:nvSpPr>
         <p:spPr>
           <a:xfrm>
-            <a:off x="5842000" y="3657600"/>
+            <a:off x="5842000" y="3784600"/>
             <a:ext cx="1574800" cy="984250"/>
           </a:xfrm>
           <a:prstGeom prst="rect">
@@ -10151,8 +10151,8 @@
         </p:nvSpPr>
         <p:spPr>
           <a:xfrm>
-            <a:off x="7670800" y="3581400"/>
-            <a:ext cx="1778000" cy="2260600"/>
+            <a:off x="7670800" y="3708400"/>
+            <a:ext cx="1778000" cy="2133600"/>
           </a:xfrm>
           <a:prstGeom prst="roundRect">
             <a:avLst>
@@ -10178,7 +10178,7 @@
         </p:nvSpPr>
         <p:spPr>
           <a:xfrm>
-            <a:off x="7772400" y="3657600"/>
+            <a:off x="7772400" y="3784600"/>
             <a:ext cx="1574800" cy="984250"/>
           </a:xfrm>
           <a:prstGeom prst="rect">
@@ -10700,8 +10700,8 @@
         </p:nvSpPr>
         <p:spPr>
           <a:xfrm>
-            <a:off x="9601200" y="3581400"/>
-            <a:ext cx="1778000" cy="2260600"/>
+            <a:off x="9601200" y="3708400"/>
+            <a:ext cx="1778000" cy="2133600"/>
           </a:xfrm>
           <a:prstGeom prst="roundRect">
             <a:avLst>
@@ -10727,7 +10727,7 @@
         </p:nvSpPr>
         <p:spPr>
           <a:xfrm>
-            <a:off x="9702800" y="3657600"/>
+            <a:off x="9702800" y="3784600"/>
             <a:ext cx="1574800" cy="984250"/>
           </a:xfrm>
           <a:prstGeom prst="rect">
@@ -11226,7 +11226,7 @@
         </p:nvSpPr>
         <p:spPr>
           <a:xfrm>
-            <a:off x="4445000" y="1758950"/>
+            <a:off x="4445000" y="2203450"/>
             <a:ext cx="127000" cy="127000"/>
           </a:xfrm>
           <a:prstGeom prst="rect">
@@ -11246,7 +11246,7 @@
         </p:nvSpPr>
         <p:spPr>
           <a:xfrm>
-            <a:off x="4635500" y="1714500"/>
+            <a:off x="4635500" y="2159000"/>
             <a:ext cx="635000" cy="215900"/>
           </a:xfrm>
           <a:prstGeom prst="rect">
@@ -11288,7 +11288,7 @@
         </p:nvSpPr>
         <p:spPr>
           <a:xfrm>
-            <a:off x="5334000" y="1758950"/>
+            <a:off x="5334000" y="2203450"/>
             <a:ext cx="127000" cy="127000"/>
           </a:xfrm>
           <a:prstGeom prst="rect">
@@ -11308,7 +11308,7 @@
         </p:nvSpPr>
         <p:spPr>
           <a:xfrm>
-            <a:off x="5524500" y="1714500"/>
+            <a:off x="5524500" y="2159000"/>
             <a:ext cx="1270000" cy="215900"/>
           </a:xfrm>
           <a:prstGeom prst="rect">
@@ -11350,7 +11350,7 @@
         </p:nvSpPr>
         <p:spPr>
           <a:xfrm>
-            <a:off x="6858000" y="1758950"/>
+            <a:off x="6858000" y="2203450"/>
             <a:ext cx="127000" cy="127000"/>
           </a:xfrm>
           <a:prstGeom prst="rect">
@@ -11370,7 +11370,7 @@
         </p:nvSpPr>
         <p:spPr>
           <a:xfrm>
-            <a:off x="7048500" y="1714500"/>
+            <a:off x="7048500" y="2159000"/>
             <a:ext cx="1651000" cy="215900"/>
           </a:xfrm>
           <a:prstGeom prst="rect">
@@ -11412,7 +11412,7 @@
         </p:nvSpPr>
         <p:spPr>
           <a:xfrm>
-            <a:off x="8763000" y="1758950"/>
+            <a:off x="8763000" y="2203450"/>
             <a:ext cx="127000" cy="127000"/>
           </a:xfrm>
           <a:prstGeom prst="rect">
@@ -11432,7 +11432,7 @@
         </p:nvSpPr>
         <p:spPr>
           <a:xfrm>
-            <a:off x="8953500" y="1714500"/>
+            <a:off x="8953500" y="2159000"/>
             <a:ext cx="1905000" cy="215900"/>
           </a:xfrm>
           <a:prstGeom prst="rect">
@@ -11474,7 +11474,7 @@
         </p:nvSpPr>
         <p:spPr>
           <a:xfrm>
-            <a:off x="812800" y="1714500"/>
+            <a:off x="812800" y="2159000"/>
             <a:ext cx="3556000" cy="215900"/>
           </a:xfrm>
           <a:prstGeom prst="rect">
@@ -11700,7 +11700,7 @@
                 <a:ea typeface="Optimist Display" pitchFamily="34" charset="-122"/>
                 <a:cs typeface="Optimist Display" pitchFamily="34" charset="-120"/>
               </a:rPr>
-              <a:t>AI shrinks BAU down to a firm risk floor, and the freed capacity builds AI work from near zero</a:t>
+              <a:t>Within two years, ~25% of BAU headcount shifts to AI growth or is released through efficiency</a:t>
             </a:r>
             <a:endParaRPr lang="en-US" sz="3200" dirty="0"/>
           </a:p>

</xml_diff>